<commit_message>
feat(tuan-06): chay thuc nghiem 100% tren Android Emulator Pixel_API_30 va Appium v3.9.0
</commit_message>
<xml_diff>
--- a/tuan-06/slide_tuan06_a1.pptx
+++ b/tuan-06/slide_tuan06_a1.pptx
@@ -4991,7 +4991,7 @@
         <p:spPr>
           <a:xfrm>
             <a:off x="6949440" y="1645920"/>
-            <a:ext cx="4480560" cy="7965440"/>
+            <a:ext cx="4480560" cy="8961120"/>
           </a:xfrm>
           <a:prstGeom prst="rect">
             <a:avLst/>
@@ -5288,7 +5288,7 @@
         <p:spPr>
           <a:xfrm>
             <a:off x="6949440" y="1645920"/>
-            <a:ext cx="4480560" cy="7965440"/>
+            <a:ext cx="4480560" cy="8961120"/>
           </a:xfrm>
           <a:prstGeom prst="rect">
             <a:avLst/>

</xml_diff>